<commit_message>
Unidade 3: produção em sala sem menu; modelos de docs do Trabalho 3
</commit_message>
<xml_diff>
--- a/slides/aula-11-construcao-incremental.pptx
+++ b/slides/aula-11-construcao-incremental.pptx
@@ -20,10 +20,9 @@
     <p:sldId id="268" r:id="rId14"/>
     <p:sldId id="269" r:id="rId15"/>
     <p:sldId id="270" r:id="rId16"/>
-    <p:sldId id="271" r:id="rId17"/>
   </p:sldIdLst>
   <p:notesMasterIdLst>
-    <p:notesMasterId r:id="rId18"/>
+    <p:notesMasterId r:id="rId17"/>
   </p:notesMasterIdLst>
   <p:sldSz cx="9144000" cy="5143500"/>
   <p:notesSz cx="5143500" cy="9144000"/>
@@ -869,7 +868,7 @@
           <a:p>
             <a:r>
               <a:rPr lang="en-US" dirty="0"/>
-              <a:t>Circular entre os grupos. Questionar decisões e introduzir restrições novas.</a:t>
+              <a:t>Sem escolha entre opções: a entrega é a mesma para todos os grupos. Circular e cobrar a evidência.</a:t>
             </a:r>
             <a:endParaRPr lang="en-US" dirty="0"/>
           </a:p>
@@ -957,7 +956,7 @@
           <a:p>
             <a:r>
               <a:rPr lang="en-US" dirty="0"/>
-              <a:t>Correção binária: entregou no prazo e no formato, pontuou.</a:t>
+              <a:t>Se for colaboradora: exigir o registro do que a IA gerou e do que eles mudaram.</a:t>
             </a:r>
             <a:endParaRPr lang="en-US" dirty="0"/>
           </a:p>
@@ -1045,7 +1044,7 @@
           <a:p>
             <a:r>
               <a:rPr lang="en-US" dirty="0"/>
-              <a:t>Se for colaboradora: exigir o registro do que a IA gerou e do que eles mudaram.</a:t>
+              <a:t>Reservar 1 min ao final. Nunca entregar resumo pronto — a consulta é evidência de aprendizagem.</a:t>
             </a:r>
             <a:endParaRPr lang="en-US" dirty="0"/>
           </a:p>
@@ -1069,94 +1068,6 @@
             <a:fld id="{F7021451-1387-4CA6-816F-3879F97B5CBC}" type="slidenum">
               <a:rPr lang="en-US"/>
               <a:t>15</a:t>
-            </a:fld>
-            <a:endParaRPr lang="en-US"/>
-          </a:p>
-        </p:txBody>
-      </p:sp>
-    </p:spTree>
-    <p:extLst>
-      <p:ext uri="{BB962C8B-B14F-4D97-AF65-F5344CB8AC3E}">
-        <p14:creationId xmlns:p14="http://schemas.microsoft.com/office/powerpoint/2010/main" val="1024086991"/>
-      </p:ext>
-    </p:extLst>
-  </p:cSld>
-  <p:clrMapOvr>
-    <a:masterClrMapping/>
-  </p:clrMapOvr>
-</p:notes>
-</file>
-
-<file path=ppt/notesSlides/notesSlide16.xml><?xml version="1.0" encoding="utf-8"?>
-<p:notes xmlns:a="http://schemas.openxmlformats.org/drawingml/2006/main" xmlns:r="http://schemas.openxmlformats.org/officeDocument/2006/relationships" xmlns:p="http://schemas.openxmlformats.org/presentationml/2006/main">
-  <p:cSld>
-    <p:spTree>
-      <p:nvGrpSpPr>
-        <p:cNvPr id="1" name=""/>
-        <p:cNvGrpSpPr/>
-        <p:nvPr/>
-      </p:nvGrpSpPr>
-      <p:grpSpPr>
-        <a:xfrm>
-          <a:off x="0" y="0"/>
-          <a:ext cx="0" cy="0"/>
-          <a:chOff x="0" y="0"/>
-          <a:chExt cx="0" cy="0"/>
-        </a:xfrm>
-      </p:grpSpPr>
-      <p:sp>
-        <p:nvSpPr>
-          <p:cNvPr id="2" name="Slide Image Placeholder 1"/>
-          <p:cNvSpPr>
-            <a:spLocks noGrp="1" noRot="1" noChangeAspect="1"/>
-          </p:cNvSpPr>
-          <p:nvPr>
-            <p:ph type="sldImg"/>
-          </p:nvPr>
-        </p:nvSpPr>
-        <p:spPr/>
-      </p:sp>
-      <p:sp>
-        <p:nvSpPr>
-          <p:cNvPr id="3" name="Notes Placeholder 2"/>
-          <p:cNvSpPr>
-            <a:spLocks noGrp="1"/>
-          </p:cNvSpPr>
-          <p:nvPr>
-            <p:ph type="body" idx="1"/>
-          </p:nvPr>
-        </p:nvSpPr>
-        <p:spPr/>
-        <p:txBody>
-          <a:bodyPr/>
-          <a:lstStyle/>
-          <a:p>
-            <a:r>
-              <a:rPr lang="en-US" dirty="0"/>
-              <a:t>Reservar 1 min ao final. Nunca entregar resumo pronto — a consulta é evidência de aprendizagem.</a:t>
-            </a:r>
-            <a:endParaRPr lang="en-US" dirty="0"/>
-          </a:p>
-        </p:txBody>
-      </p:sp>
-      <p:sp>
-        <p:nvSpPr>
-          <p:cNvPr id="4" name="Slide Number Placeholder 3"/>
-          <p:cNvSpPr>
-            <a:spLocks noGrp="1"/>
-          </p:cNvSpPr>
-          <p:nvPr>
-            <p:ph type="sldNum" sz="quarter" idx="10"/>
-          </p:nvPr>
-        </p:nvSpPr>
-        <p:spPr/>
-        <p:txBody>
-          <a:bodyPr/>
-          <a:lstStyle/>
-          <a:p>
-            <a:fld id="{F7021451-1387-4CA6-816F-3879F97B5CBC}" type="slidenum">
-              <a:rPr lang="en-US"/>
-              <a:t>16</a:t>
             </a:fld>
             <a:endParaRPr lang="en-US"/>
           </a:p>
@@ -3828,7 +3739,7 @@
                 <a:ea typeface="Cambria" pitchFamily="34" charset="-122"/>
                 <a:cs typeface="Cambria" pitchFamily="34" charset="-120"/>
               </a:rPr>
-              <a:t>Produção contínua</a:t>
+              <a:t>Produção em sala</a:t>
             </a:r>
             <a:endParaRPr lang="en-US" sz="3000" dirty="0"/>
           </a:p>
@@ -3867,7 +3778,7 @@
                 <a:ea typeface="Calibri" pitchFamily="34" charset="-122"/>
                 <a:cs typeface="Calibri" pitchFamily="34" charset="-120"/>
               </a:rPr>
-              <a:t>O que todos os grupos evoluem no produto hoje</a:t>
+              <a:t>Em construção o caminho é um só — não há menu de opções</a:t>
             </a:r>
             <a:endParaRPr lang="en-US" sz="1300" dirty="0"/>
           </a:p>
@@ -3882,11 +3793,11 @@
         <p:spPr>
           <a:xfrm>
             <a:off x="457200" y="1298448"/>
-            <a:ext cx="8229600" cy="2377440"/>
+            <a:ext cx="8229600" cy="2103120"/>
           </a:xfrm>
           <a:prstGeom prst="roundRect">
             <a:avLst>
-              <a:gd name="adj" fmla="val 5385"/>
+              <a:gd name="adj" fmla="val 6087"/>
             </a:avLst>
           </a:prstGeom>
           <a:solidFill>
@@ -3908,8 +3819,8 @@
         </p:nvSpPr>
         <p:spPr>
           <a:xfrm>
-            <a:off x="777240" y="1481328"/>
-            <a:ext cx="7589520" cy="2011680"/>
+            <a:off x="777240" y="1463040"/>
+            <a:ext cx="7589520" cy="1828800"/>
           </a:xfrm>
           <a:prstGeom prst="rect">
             <a:avLst/>
@@ -3923,13 +3834,13 @@
           <a:p>
             <a:pPr marL="342900" indent="-342900">
               <a:spcAft>
-                <a:spcPts val="1000"/>
+                <a:spcPts val="800"/>
               </a:spcAft>
               <a:buSzPct val="100000"/>
               <a:buChar char="•"/>
             </a:pPr>
             <a:r>
-              <a:rPr lang="en-US" sz="1500" dirty="0">
+              <a:rPr lang="en-US" sz="1450" dirty="0">
                 <a:solidFill>
                   <a:srgbClr val="36454F"/>
                 </a:solidFill>
@@ -3937,20 +3848,20 @@
                 <a:ea typeface="Calibri" pitchFamily="34" charset="-122"/>
                 <a:cs typeface="Calibri" pitchFamily="34" charset="-120"/>
               </a:rPr>
-              <a:t>Evoluir o produto com uma nova história priorizada, via PR revisado e CI verde.</a:t>
-            </a:r>
-            <a:endParaRPr lang="en-US" sz="1500" dirty="0"/>
+              <a:t>Evoluir o produto com uma nova história priorizada, integrada por PR revisado e CI verde.</a:t>
+            </a:r>
+            <a:endParaRPr lang="en-US" sz="1450" dirty="0"/>
           </a:p>
           <a:p>
             <a:pPr marL="342900" indent="-342900">
               <a:spcAft>
-                <a:spcPts val="1000"/>
+                <a:spcPts val="800"/>
               </a:spcAft>
               <a:buSzPct val="100000"/>
               <a:buChar char="•"/>
             </a:pPr>
             <a:r>
-              <a:rPr lang="en-US" sz="1500" dirty="0">
+              <a:rPr lang="en-US" sz="1450" dirty="0">
                 <a:solidFill>
                   <a:srgbClr val="36454F"/>
                 </a:solidFill>
@@ -3958,20 +3869,20 @@
                 <a:ea typeface="Calibri" pitchFamily="34" charset="-122"/>
                 <a:cs typeface="Calibri" pitchFamily="34" charset="-120"/>
               </a:rPr>
-              <a:t>Escrever a definição de pronto do grupo e registrar no repositório.</a:t>
-            </a:r>
-            <a:endParaRPr lang="en-US" sz="1500" dirty="0"/>
+              <a:t>Escrever a definição de pronto do grupo e registrá-la no README do repositório.</a:t>
+            </a:r>
+            <a:endParaRPr lang="en-US" sz="1450" dirty="0"/>
           </a:p>
           <a:p>
             <a:pPr marL="342900" indent="-342900">
               <a:spcAft>
-                <a:spcPts val="1000"/>
+                <a:spcPts val="800"/>
               </a:spcAft>
               <a:buSzPct val="100000"/>
               <a:buChar char="•"/>
             </a:pPr>
             <a:r>
-              <a:rPr lang="en-US" sz="1500" dirty="0">
+              <a:rPr lang="en-US" sz="1450" dirty="0">
                 <a:solidFill>
                   <a:srgbClr val="36454F"/>
                 </a:solidFill>
@@ -3981,18 +3892,18 @@
               </a:rPr>
               <a:t>Subir o PostgreSQL local (docker compose up -d) e preparar a migração do ADR.</a:t>
             </a:r>
-            <a:endParaRPr lang="en-US" sz="1500" dirty="0"/>
+            <a:endParaRPr lang="en-US" sz="1450" dirty="0"/>
           </a:p>
           <a:p>
             <a:pPr marL="342900" indent="-342900">
               <a:spcAft>
-                <a:spcPts val="1000"/>
+                <a:spcPts val="800"/>
               </a:spcAft>
               <a:buSzPct val="100000"/>
               <a:buChar char="•"/>
             </a:pPr>
             <a:r>
-              <a:rPr lang="en-US" sz="1500" dirty="0">
+              <a:rPr lang="en-US" sz="1450" dirty="0">
                 <a:solidFill>
                   <a:srgbClr val="36454F"/>
                 </a:solidFill>
@@ -4000,15 +3911,90 @@
                 <a:ea typeface="Calibri" pitchFamily="34" charset="-122"/>
                 <a:cs typeface="Calibri" pitchFamily="34" charset="-120"/>
               </a:rPr>
-              <a:t>Iniciar a consulta manuscrita da unidade 3.</a:t>
-            </a:r>
-            <a:endParaRPr lang="en-US" sz="1500" dirty="0"/>
-          </a:p>
-        </p:txBody>
-      </p:sp>
-      <p:sp>
-        <p:nvSpPr>
-          <p:cNvPr id="6" name="Text 4"/>
+              <a:t>Se usar IA para gerar código, registrar no PR o que manteve, o que mudou e por quê.</a:t>
+            </a:r>
+            <a:endParaRPr lang="en-US" sz="1450" dirty="0"/>
+          </a:p>
+        </p:txBody>
+      </p:sp>
+      <p:sp>
+        <p:nvSpPr>
+          <p:cNvPr id="6" name="Shape 4"/>
+          <p:cNvSpPr/>
+          <p:nvPr/>
+        </p:nvSpPr>
+        <p:spPr>
+          <a:xfrm>
+            <a:off x="457200" y="3566160"/>
+            <a:ext cx="8229600" cy="777240"/>
+          </a:xfrm>
+          <a:prstGeom prst="roundRect">
+            <a:avLst>
+              <a:gd name="adj" fmla="val 14118"/>
+            </a:avLst>
+          </a:prstGeom>
+          <a:solidFill>
+            <a:srgbClr val="2C5F2D"/>
+          </a:solidFill>
+          <a:ln/>
+        </p:spPr>
+      </p:sp>
+      <p:sp>
+        <p:nvSpPr>
+          <p:cNvPr id="7" name="Text 5"/>
+          <p:cNvSpPr/>
+          <p:nvPr/>
+        </p:nvSpPr>
+        <p:spPr>
+          <a:xfrm>
+            <a:off x="731520" y="3566160"/>
+            <a:ext cx="7680960" cy="777240"/>
+          </a:xfrm>
+          <a:prstGeom prst="rect">
+            <a:avLst/>
+          </a:prstGeom>
+          <a:noFill/>
+          <a:ln/>
+        </p:spPr>
+        <p:txBody>
+          <a:bodyPr wrap="square" lIns="0" tIns="0" rIns="0" bIns="0" rtlCol="0" anchor="ctr"/>
+          <a:lstStyle/>
+          <a:p>
+            <a:pPr indent="0" marL="0">
+              <a:buNone/>
+            </a:pPr>
+            <a:r>
+              <a:rPr lang="en-US" sz="1400" b="1" dirty="0">
+                <a:solidFill>
+                  <a:srgbClr val="FFFFFF"/>
+                </a:solidFill>
+                <a:latin typeface="Calibri" pitchFamily="34" charset="0"/>
+                <a:ea typeface="Calibri" pitchFamily="34" charset="-122"/>
+                <a:cs typeface="Calibri" pitchFamily="34" charset="-120"/>
+              </a:rPr>
+              <a:t>Entrega do encontro: </a:t>
+            </a:r>
+            <a:pPr indent="0" marL="0">
+              <a:buNone/>
+            </a:pPr>
+            <a:r>
+              <a:rPr lang="en-US" sz="1400" dirty="0">
+                <a:solidFill>
+                  <a:srgbClr val="FFFFFF"/>
+                </a:solidFill>
+                <a:latin typeface="Calibri" pitchFamily="34" charset="0"/>
+                <a:ea typeface="Calibri" pitchFamily="34" charset="-122"/>
+                <a:cs typeface="Calibri" pitchFamily="34" charset="-120"/>
+              </a:rPr>
+              <a:t>o PR da história e a definição de pronto no repositório</a:t>
+            </a:r>
+            <a:endParaRPr lang="en-US" sz="1400" dirty="0"/>
+          </a:p>
+        </p:txBody>
+      </p:sp>
+      <p:sp>
+        <p:nvSpPr>
+          <p:cNvPr id="8" name="Text 6"/>
           <p:cNvSpPr/>
           <p:nvPr/>
         </p:nvSpPr>
@@ -4039,7 +4025,7 @@
                 <a:ea typeface="Calibri" pitchFamily="34" charset="-122"/>
                 <a:cs typeface="Calibri" pitchFamily="34" charset="-120"/>
               </a:rPr>
-              <a:t>Produção · o produto vivo avança em toda aula</a:t>
+              <a:t>Vale os 0,25 da atividade do encontro</a:t>
             </a:r>
             <a:endParaRPr lang="en-US" sz="1000" dirty="0"/>
           </a:p>
@@ -4103,7 +4089,7 @@
                 <a:ea typeface="Cambria" pitchFamily="34" charset="-122"/>
                 <a:cs typeface="Cambria" pitchFamily="34" charset="-120"/>
               </a:rPr>
-              <a:t>Trabalho em sala</a:t>
+              <a:t>Nível de IA nesta aula</a:t>
             </a:r>
             <a:endParaRPr lang="en-US" sz="3000" dirty="0"/>
           </a:p>
@@ -4111,83 +4097,19 @@
       </p:sp>
       <p:sp>
         <p:nvSpPr>
-          <p:cNvPr id="3" name="Text 1"/>
-          <p:cNvSpPr/>
-          <p:nvPr/>
-        </p:nvSpPr>
-        <p:spPr>
-          <a:xfrm>
-            <a:off x="457200" y="868680"/>
-            <a:ext cx="8229600" cy="274320"/>
-          </a:xfrm>
-          <a:prstGeom prst="rect">
-            <a:avLst/>
-          </a:prstGeom>
-          <a:noFill/>
-          <a:ln/>
-        </p:spPr>
-        <p:txBody>
-          <a:bodyPr wrap="square" lIns="0" tIns="0" rIns="0" bIns="0" rtlCol="0" anchor="ctr"/>
-          <a:lstStyle/>
-          <a:p>
-            <a:pPr indent="0" marL="0">
-              <a:buNone/>
-            </a:pPr>
-            <a:r>
-              <a:rPr lang="en-US" sz="1300" i="1" dirty="0">
-                <a:solidFill>
-                  <a:srgbClr val="6E7D72"/>
-                </a:solidFill>
-                <a:latin typeface="Calibri" pitchFamily="34" charset="0"/>
-                <a:ea typeface="Calibri" pitchFamily="34" charset="-122"/>
-                <a:cs typeface="Calibri" pitchFamily="34" charset="-120"/>
-              </a:rPr>
-              <a:t>Em grupo (3 a 5 pessoas) — escolham 1 das 3 opções</a:t>
-            </a:r>
-            <a:endParaRPr lang="en-US" sz="1300" dirty="0"/>
-          </a:p>
-        </p:txBody>
-      </p:sp>
-      <p:sp>
-        <p:nvSpPr>
-          <p:cNvPr id="4" name="Shape 2"/>
-          <p:cNvSpPr/>
-          <p:nvPr/>
-        </p:nvSpPr>
-        <p:spPr>
-          <a:xfrm>
-            <a:off x="457200" y="1298448"/>
-            <a:ext cx="8229600" cy="960120"/>
+          <p:cNvPr id="3" name="Shape 1"/>
+          <p:cNvSpPr/>
+          <p:nvPr/>
+        </p:nvSpPr>
+        <p:spPr>
+          <a:xfrm>
+            <a:off x="457200" y="1143000"/>
+            <a:ext cx="8229600" cy="1051560"/>
           </a:xfrm>
           <a:prstGeom prst="roundRect">
             <a:avLst>
-              <a:gd name="adj" fmla="val 11429"/>
+              <a:gd name="adj" fmla="val 12174"/>
             </a:avLst>
-          </a:prstGeom>
-          <a:solidFill>
-            <a:srgbClr val="FFFFFF"/>
-          </a:solidFill>
-          <a:ln w="12700">
-            <a:solidFill>
-              <a:srgbClr val="D6E0D2"/>
-            </a:solidFill>
-            <a:prstDash val="solid"/>
-          </a:ln>
-        </p:spPr>
-      </p:sp>
-      <p:sp>
-        <p:nvSpPr>
-          <p:cNvPr id="5" name="Shape 3"/>
-          <p:cNvSpPr/>
-          <p:nvPr/>
-        </p:nvSpPr>
-        <p:spPr>
-          <a:xfrm>
-            <a:off x="658368" y="1591056"/>
-            <a:ext cx="384048" cy="384048"/>
-          </a:xfrm>
-          <a:prstGeom prst="ellipse">
-            <a:avLst/>
           </a:prstGeom>
           <a:solidFill>
             <a:srgbClr val="2C5F2D"/>
@@ -4197,14 +4119,92 @@
       </p:sp>
       <p:sp>
         <p:nvSpPr>
+          <p:cNvPr id="4" name="Text 2"/>
+          <p:cNvSpPr/>
+          <p:nvPr/>
+        </p:nvSpPr>
+        <p:spPr>
+          <a:xfrm>
+            <a:off x="457200" y="1143000"/>
+            <a:ext cx="8229600" cy="1051560"/>
+          </a:xfrm>
+          <a:prstGeom prst="rect">
+            <a:avLst/>
+          </a:prstGeom>
+          <a:noFill/>
+          <a:ln/>
+        </p:spPr>
+        <p:txBody>
+          <a:bodyPr wrap="square" lIns="0" tIns="0" rIns="0" bIns="0" rtlCol="0" anchor="ctr"/>
+          <a:lstStyle/>
+          <a:p>
+            <a:pPr algn="ctr" indent="0" marL="0">
+              <a:buNone/>
+            </a:pPr>
+            <a:r>
+              <a:rPr lang="en-US" sz="2600" b="1" dirty="0">
+                <a:solidFill>
+                  <a:srgbClr val="FFFFFF"/>
+                </a:solidFill>
+                <a:latin typeface="Cambria" pitchFamily="34" charset="0"/>
+                <a:ea typeface="Cambria" pitchFamily="34" charset="-122"/>
+                <a:cs typeface="Cambria" pitchFamily="34" charset="-120"/>
+              </a:rPr>
+              <a:t>IA como colaboradora</a:t>
+            </a:r>
+            <a:endParaRPr lang="en-US" sz="2600" dirty="0"/>
+          </a:p>
+        </p:txBody>
+      </p:sp>
+      <p:sp>
+        <p:nvSpPr>
+          <p:cNvPr id="5" name="Text 3"/>
+          <p:cNvSpPr/>
+          <p:nvPr/>
+        </p:nvSpPr>
+        <p:spPr>
+          <a:xfrm>
+            <a:off x="457200" y="2377440"/>
+            <a:ext cx="8229600" cy="640080"/>
+          </a:xfrm>
+          <a:prstGeom prst="rect">
+            <a:avLst/>
+          </a:prstGeom>
+          <a:noFill/>
+          <a:ln/>
+        </p:spPr>
+        <p:txBody>
+          <a:bodyPr wrap="square" lIns="0" tIns="0" rIns="0" bIns="0" rtlCol="0" anchor="ctr"/>
+          <a:lstStyle/>
+          <a:p>
+            <a:pPr indent="0" marL="0">
+              <a:buNone/>
+            </a:pPr>
+            <a:r>
+              <a:rPr lang="en-US" sz="1500" dirty="0">
+                <a:solidFill>
+                  <a:srgbClr val="36454F"/>
+                </a:solidFill>
+                <a:latin typeface="Calibri" pitchFamily="34" charset="0"/>
+                <a:ea typeface="Calibri" pitchFamily="34" charset="-122"/>
+                <a:cs typeface="Calibri" pitchFamily="34" charset="-120"/>
+              </a:rPr>
+              <a:t>Pode gerar código. Você revisa, testa e registra no PR o que manteve, o que mudou e por quê.</a:t>
+            </a:r>
+            <a:endParaRPr lang="en-US" sz="1500" dirty="0"/>
+          </a:p>
+        </p:txBody>
+      </p:sp>
+      <p:sp>
+        <p:nvSpPr>
           <p:cNvPr id="6" name="Text 4"/>
           <p:cNvSpPr/>
           <p:nvPr/>
         </p:nvSpPr>
         <p:spPr>
           <a:xfrm>
-            <a:off x="658368" y="1591056"/>
-            <a:ext cx="384048" cy="384048"/>
+            <a:off x="457200" y="3108960"/>
+            <a:ext cx="8229600" cy="548640"/>
           </a:xfrm>
           <a:prstGeom prst="rect">
             <a:avLst/>
@@ -4216,316 +4216,27 @@
           <a:bodyPr wrap="square" lIns="0" tIns="0" rIns="0" bIns="0" rtlCol="0" anchor="ctr"/>
           <a:lstStyle/>
           <a:p>
-            <a:pPr algn="ctr" indent="0" marL="0">
-              <a:buNone/>
-            </a:pPr>
-            <a:r>
-              <a:rPr lang="en-US" sz="1500" b="1" dirty="0">
-                <a:solidFill>
-                  <a:srgbClr val="FFFFFF"/>
-                </a:solidFill>
-                <a:latin typeface="Calibri" pitchFamily="34" charset="0"/>
-                <a:ea typeface="Calibri" pitchFamily="34" charset="-122"/>
-                <a:cs typeface="Calibri" pitchFamily="34" charset="-120"/>
-              </a:rPr>
-              <a:t>1</a:t>
-            </a:r>
-            <a:endParaRPr lang="en-US" sz="1500" dirty="0"/>
+            <a:pPr indent="0" marL="0">
+              <a:buNone/>
+            </a:pPr>
+            <a:r>
+              <a:rPr lang="en-US" sz="1300" i="1" dirty="0">
+                <a:solidFill>
+                  <a:srgbClr val="6E7D72"/>
+                </a:solidFill>
+                <a:latin typeface="Calibri" pitchFamily="34" charset="0"/>
+                <a:ea typeface="Calibri" pitchFamily="34" charset="-122"/>
+                <a:cs typeface="Calibri" pitchFamily="34" charset="-120"/>
+              </a:rPr>
+              <a:t>Em qualquer nível, você continua responsável por verificar, testar, corrigir e defender o resultado.</a:t>
+            </a:r>
+            <a:endParaRPr lang="en-US" sz="1300" dirty="0"/>
           </a:p>
         </p:txBody>
       </p:sp>
       <p:sp>
         <p:nvSpPr>
           <p:cNvPr id="7" name="Text 5"/>
-          <p:cNvSpPr/>
-          <p:nvPr/>
-        </p:nvSpPr>
-        <p:spPr>
-          <a:xfrm>
-            <a:off x="1234440" y="1298448"/>
-            <a:ext cx="7223760" cy="960120"/>
-          </a:xfrm>
-          <a:prstGeom prst="rect">
-            <a:avLst/>
-          </a:prstGeom>
-          <a:noFill/>
-          <a:ln/>
-        </p:spPr>
-        <p:txBody>
-          <a:bodyPr wrap="square" lIns="0" tIns="0" rIns="0" bIns="0" rtlCol="0" anchor="ctr"/>
-          <a:lstStyle/>
-          <a:p>
-            <a:pPr indent="0" marL="0">
-              <a:buNone/>
-            </a:pPr>
-            <a:r>
-              <a:rPr lang="en-US" sz="1350" dirty="0">
-                <a:solidFill>
-                  <a:srgbClr val="36454F"/>
-                </a:solidFill>
-                <a:latin typeface="Calibri" pitchFamily="34" charset="0"/>
-                <a:ea typeface="Calibri" pitchFamily="34" charset="-122"/>
-                <a:cs typeface="Calibri" pitchFamily="34" charset="-120"/>
-              </a:rPr>
-              <a:t>Implementar o primeiro incremento de uma história e abrir o PR com mensagem clara.</a:t>
-            </a:r>
-            <a:endParaRPr lang="en-US" sz="1350" dirty="0"/>
-          </a:p>
-        </p:txBody>
-      </p:sp>
-      <p:sp>
-        <p:nvSpPr>
-          <p:cNvPr id="8" name="Shape 6"/>
-          <p:cNvSpPr/>
-          <p:nvPr/>
-        </p:nvSpPr>
-        <p:spPr>
-          <a:xfrm>
-            <a:off x="457200" y="2404872"/>
-            <a:ext cx="8229600" cy="960120"/>
-          </a:xfrm>
-          <a:prstGeom prst="roundRect">
-            <a:avLst>
-              <a:gd name="adj" fmla="val 11429"/>
-            </a:avLst>
-          </a:prstGeom>
-          <a:solidFill>
-            <a:srgbClr val="FFFFFF"/>
-          </a:solidFill>
-          <a:ln w="12700">
-            <a:solidFill>
-              <a:srgbClr val="D6E0D2"/>
-            </a:solidFill>
-            <a:prstDash val="solid"/>
-          </a:ln>
-        </p:spPr>
-      </p:sp>
-      <p:sp>
-        <p:nvSpPr>
-          <p:cNvPr id="9" name="Shape 7"/>
-          <p:cNvSpPr/>
-          <p:nvPr/>
-        </p:nvSpPr>
-        <p:spPr>
-          <a:xfrm>
-            <a:off x="658368" y="2697480"/>
-            <a:ext cx="384048" cy="384048"/>
-          </a:xfrm>
-          <a:prstGeom prst="ellipse">
-            <a:avLst/>
-          </a:prstGeom>
-          <a:solidFill>
-            <a:srgbClr val="2C5F2D"/>
-          </a:solidFill>
-          <a:ln/>
-        </p:spPr>
-      </p:sp>
-      <p:sp>
-        <p:nvSpPr>
-          <p:cNvPr id="10" name="Text 8"/>
-          <p:cNvSpPr/>
-          <p:nvPr/>
-        </p:nvSpPr>
-        <p:spPr>
-          <a:xfrm>
-            <a:off x="658368" y="2697480"/>
-            <a:ext cx="384048" cy="384048"/>
-          </a:xfrm>
-          <a:prstGeom prst="rect">
-            <a:avLst/>
-          </a:prstGeom>
-          <a:noFill/>
-          <a:ln/>
-        </p:spPr>
-        <p:txBody>
-          <a:bodyPr wrap="square" lIns="0" tIns="0" rIns="0" bIns="0" rtlCol="0" anchor="ctr"/>
-          <a:lstStyle/>
-          <a:p>
-            <a:pPr algn="ctr" indent="0" marL="0">
-              <a:buNone/>
-            </a:pPr>
-            <a:r>
-              <a:rPr lang="en-US" sz="1500" b="1" dirty="0">
-                <a:solidFill>
-                  <a:srgbClr val="FFFFFF"/>
-                </a:solidFill>
-                <a:latin typeface="Calibri" pitchFamily="34" charset="0"/>
-                <a:ea typeface="Calibri" pitchFamily="34" charset="-122"/>
-                <a:cs typeface="Calibri" pitchFamily="34" charset="-120"/>
-              </a:rPr>
-              <a:t>2</a:t>
-            </a:r>
-            <a:endParaRPr lang="en-US" sz="1500" dirty="0"/>
-          </a:p>
-        </p:txBody>
-      </p:sp>
-      <p:sp>
-        <p:nvSpPr>
-          <p:cNvPr id="11" name="Text 9"/>
-          <p:cNvSpPr/>
-          <p:nvPr/>
-        </p:nvSpPr>
-        <p:spPr>
-          <a:xfrm>
-            <a:off x="1234440" y="2404872"/>
-            <a:ext cx="7223760" cy="960120"/>
-          </a:xfrm>
-          <a:prstGeom prst="rect">
-            <a:avLst/>
-          </a:prstGeom>
-          <a:noFill/>
-          <a:ln/>
-        </p:spPr>
-        <p:txBody>
-          <a:bodyPr wrap="square" lIns="0" tIns="0" rIns="0" bIns="0" rtlCol="0" anchor="ctr"/>
-          <a:lstStyle/>
-          <a:p>
-            <a:pPr indent="0" marL="0">
-              <a:buNone/>
-            </a:pPr>
-            <a:r>
-              <a:rPr lang="en-US" sz="1350" dirty="0">
-                <a:solidFill>
-                  <a:srgbClr val="36454F"/>
-                </a:solidFill>
-                <a:latin typeface="Calibri" pitchFamily="34" charset="0"/>
-                <a:ea typeface="Calibri" pitchFamily="34" charset="-122"/>
-                <a:cs typeface="Calibri" pitchFamily="34" charset="-120"/>
-              </a:rPr>
-              <a:t>Definir a "definição de pronto" do grupo e aplicá-la ao incremento produzido.</a:t>
-            </a:r>
-            <a:endParaRPr lang="en-US" sz="1350" dirty="0"/>
-          </a:p>
-        </p:txBody>
-      </p:sp>
-      <p:sp>
-        <p:nvSpPr>
-          <p:cNvPr id="12" name="Shape 10"/>
-          <p:cNvSpPr/>
-          <p:nvPr/>
-        </p:nvSpPr>
-        <p:spPr>
-          <a:xfrm>
-            <a:off x="457200" y="3511296"/>
-            <a:ext cx="8229600" cy="960120"/>
-          </a:xfrm>
-          <a:prstGeom prst="roundRect">
-            <a:avLst>
-              <a:gd name="adj" fmla="val 11429"/>
-            </a:avLst>
-          </a:prstGeom>
-          <a:solidFill>
-            <a:srgbClr val="FFFFFF"/>
-          </a:solidFill>
-          <a:ln w="12700">
-            <a:solidFill>
-              <a:srgbClr val="D6E0D2"/>
-            </a:solidFill>
-            <a:prstDash val="solid"/>
-          </a:ln>
-        </p:spPr>
-      </p:sp>
-      <p:sp>
-        <p:nvSpPr>
-          <p:cNvPr id="13" name="Shape 11"/>
-          <p:cNvSpPr/>
-          <p:nvPr/>
-        </p:nvSpPr>
-        <p:spPr>
-          <a:xfrm>
-            <a:off x="658368" y="3803904"/>
-            <a:ext cx="384048" cy="384048"/>
-          </a:xfrm>
-          <a:prstGeom prst="ellipse">
-            <a:avLst/>
-          </a:prstGeom>
-          <a:solidFill>
-            <a:srgbClr val="2C5F2D"/>
-          </a:solidFill>
-          <a:ln/>
-        </p:spPr>
-      </p:sp>
-      <p:sp>
-        <p:nvSpPr>
-          <p:cNvPr id="14" name="Text 12"/>
-          <p:cNvSpPr/>
-          <p:nvPr/>
-        </p:nvSpPr>
-        <p:spPr>
-          <a:xfrm>
-            <a:off x="658368" y="3803904"/>
-            <a:ext cx="384048" cy="384048"/>
-          </a:xfrm>
-          <a:prstGeom prst="rect">
-            <a:avLst/>
-          </a:prstGeom>
-          <a:noFill/>
-          <a:ln/>
-        </p:spPr>
-        <p:txBody>
-          <a:bodyPr wrap="square" lIns="0" tIns="0" rIns="0" bIns="0" rtlCol="0" anchor="ctr"/>
-          <a:lstStyle/>
-          <a:p>
-            <a:pPr algn="ctr" indent="0" marL="0">
-              <a:buNone/>
-            </a:pPr>
-            <a:r>
-              <a:rPr lang="en-US" sz="1500" b="1" dirty="0">
-                <a:solidFill>
-                  <a:srgbClr val="FFFFFF"/>
-                </a:solidFill>
-                <a:latin typeface="Calibri" pitchFamily="34" charset="0"/>
-                <a:ea typeface="Calibri" pitchFamily="34" charset="-122"/>
-                <a:cs typeface="Calibri" pitchFamily="34" charset="-120"/>
-              </a:rPr>
-              <a:t>3</a:t>
-            </a:r>
-            <a:endParaRPr lang="en-US" sz="1500" dirty="0"/>
-          </a:p>
-        </p:txBody>
-      </p:sp>
-      <p:sp>
-        <p:nvSpPr>
-          <p:cNvPr id="15" name="Text 13"/>
-          <p:cNvSpPr/>
-          <p:nvPr/>
-        </p:nvSpPr>
-        <p:spPr>
-          <a:xfrm>
-            <a:off x="1234440" y="3511296"/>
-            <a:ext cx="7223760" cy="960120"/>
-          </a:xfrm>
-          <a:prstGeom prst="rect">
-            <a:avLst/>
-          </a:prstGeom>
-          <a:noFill/>
-          <a:ln/>
-        </p:spPr>
-        <p:txBody>
-          <a:bodyPr wrap="square" lIns="0" tIns="0" rIns="0" bIns="0" rtlCol="0" anchor="ctr"/>
-          <a:lstStyle/>
-          <a:p>
-            <a:pPr indent="0" marL="0">
-              <a:buNone/>
-            </a:pPr>
-            <a:r>
-              <a:rPr lang="en-US" sz="1350" dirty="0">
-                <a:solidFill>
-                  <a:srgbClr val="36454F"/>
-                </a:solidFill>
-                <a:latin typeface="Calibri" pitchFamily="34" charset="0"/>
-                <a:ea typeface="Calibri" pitchFamily="34" charset="-122"/>
-                <a:cs typeface="Calibri" pitchFamily="34" charset="-120"/>
-              </a:rPr>
-              <a:t>Gerar um trecho com IA e revisá-lo, registrando no PR o que foi mantido, o que mudou e por quê.</a:t>
-            </a:r>
-            <a:endParaRPr lang="en-US" sz="1350" dirty="0"/>
-          </a:p>
-        </p:txBody>
-      </p:sp>
-      <p:sp>
-        <p:nvSpPr>
-          <p:cNvPr id="16" name="Text 14"/>
           <p:cNvSpPr/>
           <p:nvPr/>
         </p:nvSpPr>
@@ -4556,7 +4267,7 @@
                 <a:ea typeface="Calibri" pitchFamily="34" charset="-122"/>
                 <a:cs typeface="Calibri" pitchFamily="34" charset="-120"/>
               </a:rPr>
-              <a:t>Entrega ao final do encontro · vale 0,25</a:t>
+              <a:t>Premissa 3 · o nível é declarado em toda atividade</a:t>
             </a:r>
             <a:endParaRPr lang="en-US" sz="1000" dirty="0"/>
           </a:p>
@@ -4573,248 +4284,6 @@
 <file path=ppt/slides/slide15.xml><?xml version="1.0" encoding="utf-8"?>
 <p:sld xmlns:a="http://schemas.openxmlformats.org/drawingml/2006/main" xmlns:r="http://schemas.openxmlformats.org/officeDocument/2006/relationships" xmlns:p="http://schemas.openxmlformats.org/presentationml/2006/main">
   <p:cSld name="Slide 15">
-    <p:spTree>
-      <p:nvGrpSpPr>
-        <p:cNvPr id="1" name=""/>
-        <p:cNvGrpSpPr/>
-        <p:nvPr/>
-      </p:nvGrpSpPr>
-      <p:grpSpPr>
-        <a:xfrm>
-          <a:off x="0" y="0"/>
-          <a:ext cx="0" cy="0"/>
-          <a:chOff x="0" y="0"/>
-          <a:chExt cx="0" cy="0"/>
-        </a:xfrm>
-      </p:grpSpPr>
-      <p:sp>
-        <p:nvSpPr>
-          <p:cNvPr id="2" name="Text 0"/>
-          <p:cNvSpPr/>
-          <p:nvPr/>
-        </p:nvSpPr>
-        <p:spPr>
-          <a:xfrm>
-            <a:off x="457200" y="310896"/>
-            <a:ext cx="8229600" cy="548640"/>
-          </a:xfrm>
-          <a:prstGeom prst="rect">
-            <a:avLst/>
-          </a:prstGeom>
-          <a:noFill/>
-          <a:ln/>
-        </p:spPr>
-        <p:txBody>
-          <a:bodyPr wrap="square" lIns="0" tIns="0" rIns="0" bIns="0" rtlCol="0" anchor="ctr"/>
-          <a:lstStyle/>
-          <a:p>
-            <a:pPr indent="0" marL="0">
-              <a:buNone/>
-            </a:pPr>
-            <a:r>
-              <a:rPr lang="en-US" sz="3000" b="1" dirty="0">
-                <a:solidFill>
-                  <a:srgbClr val="2C5F2D"/>
-                </a:solidFill>
-                <a:latin typeface="Cambria" pitchFamily="34" charset="0"/>
-                <a:ea typeface="Cambria" pitchFamily="34" charset="-122"/>
-                <a:cs typeface="Cambria" pitchFamily="34" charset="-120"/>
-              </a:rPr>
-              <a:t>Nível de IA nesta aula</a:t>
-            </a:r>
-            <a:endParaRPr lang="en-US" sz="3000" dirty="0"/>
-          </a:p>
-        </p:txBody>
-      </p:sp>
-      <p:sp>
-        <p:nvSpPr>
-          <p:cNvPr id="3" name="Shape 1"/>
-          <p:cNvSpPr/>
-          <p:nvPr/>
-        </p:nvSpPr>
-        <p:spPr>
-          <a:xfrm>
-            <a:off x="457200" y="1143000"/>
-            <a:ext cx="8229600" cy="1051560"/>
-          </a:xfrm>
-          <a:prstGeom prst="roundRect">
-            <a:avLst>
-              <a:gd name="adj" fmla="val 12174"/>
-            </a:avLst>
-          </a:prstGeom>
-          <a:solidFill>
-            <a:srgbClr val="2C5F2D"/>
-          </a:solidFill>
-          <a:ln/>
-        </p:spPr>
-      </p:sp>
-      <p:sp>
-        <p:nvSpPr>
-          <p:cNvPr id="4" name="Text 2"/>
-          <p:cNvSpPr/>
-          <p:nvPr/>
-        </p:nvSpPr>
-        <p:spPr>
-          <a:xfrm>
-            <a:off x="457200" y="1143000"/>
-            <a:ext cx="8229600" cy="1051560"/>
-          </a:xfrm>
-          <a:prstGeom prst="rect">
-            <a:avLst/>
-          </a:prstGeom>
-          <a:noFill/>
-          <a:ln/>
-        </p:spPr>
-        <p:txBody>
-          <a:bodyPr wrap="square" lIns="0" tIns="0" rIns="0" bIns="0" rtlCol="0" anchor="ctr"/>
-          <a:lstStyle/>
-          <a:p>
-            <a:pPr algn="ctr" indent="0" marL="0">
-              <a:buNone/>
-            </a:pPr>
-            <a:r>
-              <a:rPr lang="en-US" sz="2600" b="1" dirty="0">
-                <a:solidFill>
-                  <a:srgbClr val="FFFFFF"/>
-                </a:solidFill>
-                <a:latin typeface="Cambria" pitchFamily="34" charset="0"/>
-                <a:ea typeface="Cambria" pitchFamily="34" charset="-122"/>
-                <a:cs typeface="Cambria" pitchFamily="34" charset="-120"/>
-              </a:rPr>
-              <a:t>IA como colaboradora</a:t>
-            </a:r>
-            <a:endParaRPr lang="en-US" sz="2600" dirty="0"/>
-          </a:p>
-        </p:txBody>
-      </p:sp>
-      <p:sp>
-        <p:nvSpPr>
-          <p:cNvPr id="5" name="Text 3"/>
-          <p:cNvSpPr/>
-          <p:nvPr/>
-        </p:nvSpPr>
-        <p:spPr>
-          <a:xfrm>
-            <a:off x="457200" y="2377440"/>
-            <a:ext cx="8229600" cy="640080"/>
-          </a:xfrm>
-          <a:prstGeom prst="rect">
-            <a:avLst/>
-          </a:prstGeom>
-          <a:noFill/>
-          <a:ln/>
-        </p:spPr>
-        <p:txBody>
-          <a:bodyPr wrap="square" lIns="0" tIns="0" rIns="0" bIns="0" rtlCol="0" anchor="ctr"/>
-          <a:lstStyle/>
-          <a:p>
-            <a:pPr indent="0" marL="0">
-              <a:buNone/>
-            </a:pPr>
-            <a:r>
-              <a:rPr lang="en-US" sz="1500" dirty="0">
-                <a:solidFill>
-                  <a:srgbClr val="36454F"/>
-                </a:solidFill>
-                <a:latin typeface="Calibri" pitchFamily="34" charset="0"/>
-                <a:ea typeface="Calibri" pitchFamily="34" charset="-122"/>
-                <a:cs typeface="Calibri" pitchFamily="34" charset="-120"/>
-              </a:rPr>
-              <a:t>Pode gerar código. Você revisa, testa e registra no PR o que manteve, o que mudou e por quê.</a:t>
-            </a:r>
-            <a:endParaRPr lang="en-US" sz="1500" dirty="0"/>
-          </a:p>
-        </p:txBody>
-      </p:sp>
-      <p:sp>
-        <p:nvSpPr>
-          <p:cNvPr id="6" name="Text 4"/>
-          <p:cNvSpPr/>
-          <p:nvPr/>
-        </p:nvSpPr>
-        <p:spPr>
-          <a:xfrm>
-            <a:off x="457200" y="3108960"/>
-            <a:ext cx="8229600" cy="548640"/>
-          </a:xfrm>
-          <a:prstGeom prst="rect">
-            <a:avLst/>
-          </a:prstGeom>
-          <a:noFill/>
-          <a:ln/>
-        </p:spPr>
-        <p:txBody>
-          <a:bodyPr wrap="square" lIns="0" tIns="0" rIns="0" bIns="0" rtlCol="0" anchor="ctr"/>
-          <a:lstStyle/>
-          <a:p>
-            <a:pPr indent="0" marL="0">
-              <a:buNone/>
-            </a:pPr>
-            <a:r>
-              <a:rPr lang="en-US" sz="1300" i="1" dirty="0">
-                <a:solidFill>
-                  <a:srgbClr val="6E7D72"/>
-                </a:solidFill>
-                <a:latin typeface="Calibri" pitchFamily="34" charset="0"/>
-                <a:ea typeface="Calibri" pitchFamily="34" charset="-122"/>
-                <a:cs typeface="Calibri" pitchFamily="34" charset="-120"/>
-              </a:rPr>
-              <a:t>Em qualquer nível, você continua responsável por verificar, testar, corrigir e defender o resultado.</a:t>
-            </a:r>
-            <a:endParaRPr lang="en-US" sz="1300" dirty="0"/>
-          </a:p>
-        </p:txBody>
-      </p:sp>
-      <p:sp>
-        <p:nvSpPr>
-          <p:cNvPr id="7" name="Text 5"/>
-          <p:cNvSpPr/>
-          <p:nvPr/>
-        </p:nvSpPr>
-        <p:spPr>
-          <a:xfrm>
-            <a:off x="457200" y="4759452"/>
-            <a:ext cx="8229600" cy="256032"/>
-          </a:xfrm>
-          <a:prstGeom prst="rect">
-            <a:avLst/>
-          </a:prstGeom>
-          <a:noFill/>
-          <a:ln/>
-        </p:spPr>
-        <p:txBody>
-          <a:bodyPr wrap="square" lIns="0" tIns="0" rIns="0" bIns="0" rtlCol="0" anchor="ctr"/>
-          <a:lstStyle/>
-          <a:p>
-            <a:pPr indent="0" marL="0">
-              <a:buNone/>
-            </a:pPr>
-            <a:r>
-              <a:rPr lang="en-US" sz="1000" dirty="0">
-                <a:solidFill>
-                  <a:srgbClr val="6E7D72"/>
-                </a:solidFill>
-                <a:latin typeface="Calibri" pitchFamily="34" charset="0"/>
-                <a:ea typeface="Calibri" pitchFamily="34" charset="-122"/>
-                <a:cs typeface="Calibri" pitchFamily="34" charset="-120"/>
-              </a:rPr>
-              <a:t>Premissa 3 · o nível é declarado em toda atividade</a:t>
-            </a:r>
-            <a:endParaRPr lang="en-US" sz="1000" dirty="0"/>
-          </a:p>
-        </p:txBody>
-      </p:sp>
-    </p:spTree>
-  </p:cSld>
-  <p:clrMapOvr>
-    <a:masterClrMapping/>
-  </p:clrMapOvr>
-</p:sld>
-</file>
-
-<file path=ppt/slides/slide16.xml><?xml version="1.0" encoding="utf-8"?>
-<p:sld xmlns:a="http://schemas.openxmlformats.org/drawingml/2006/main" xmlns:r="http://schemas.openxmlformats.org/officeDocument/2006/relationships" xmlns:p="http://schemas.openxmlformats.org/presentationml/2006/main">
-  <p:cSld name="Slide 16">
     <p:bg>
       <p:bgPr>
         <a:solidFill>

</xml_diff>